<commit_message>
Fix texts that overflow on slides and implement polling for slide PPTX download
</commit_message>
<xml_diff>
--- a/apps/md-backend/src/main/resources/templates/master_templates_3j.pptx
+++ b/apps/md-backend/src/main/resources/templates/master_templates_3j.pptx
@@ -265,7 +265,7 @@
           <a:p>
             <a:fld id="{45F062A3-8868-478A-95F9-B75BA86CF6E5}" type="datetimeFigureOut">
               <a:rPr lang="es-PE" smtClean="0"/>
-              <a:t>11/09/2026</a:t>
+              <a:t>16/09/2026</a:t>
             </a:fld>
             <a:endParaRPr lang="es-PE"/>
           </a:p>
@@ -465,7 +465,7 @@
           <a:p>
             <a:fld id="{45F062A3-8868-478A-95F9-B75BA86CF6E5}" type="datetimeFigureOut">
               <a:rPr lang="es-PE" smtClean="0"/>
-              <a:t>11/09/2026</a:t>
+              <a:t>16/09/2026</a:t>
             </a:fld>
             <a:endParaRPr lang="es-PE"/>
           </a:p>
@@ -675,7 +675,7 @@
           <a:p>
             <a:fld id="{45F062A3-8868-478A-95F9-B75BA86CF6E5}" type="datetimeFigureOut">
               <a:rPr lang="es-PE" smtClean="0"/>
-              <a:t>11/09/2026</a:t>
+              <a:t>16/09/2026</a:t>
             </a:fld>
             <a:endParaRPr lang="es-PE"/>
           </a:p>
@@ -875,7 +875,7 @@
           <a:p>
             <a:fld id="{45F062A3-8868-478A-95F9-B75BA86CF6E5}" type="datetimeFigureOut">
               <a:rPr lang="es-PE" smtClean="0"/>
-              <a:t>11/09/2026</a:t>
+              <a:t>16/09/2026</a:t>
             </a:fld>
             <a:endParaRPr lang="es-PE"/>
           </a:p>
@@ -1151,7 +1151,7 @@
           <a:p>
             <a:fld id="{45F062A3-8868-478A-95F9-B75BA86CF6E5}" type="datetimeFigureOut">
               <a:rPr lang="es-PE" smtClean="0"/>
-              <a:t>11/09/2026</a:t>
+              <a:t>16/09/2026</a:t>
             </a:fld>
             <a:endParaRPr lang="es-PE"/>
           </a:p>
@@ -1419,7 +1419,7 @@
           <a:p>
             <a:fld id="{45F062A3-8868-478A-95F9-B75BA86CF6E5}" type="datetimeFigureOut">
               <a:rPr lang="es-PE" smtClean="0"/>
-              <a:t>11/09/2026</a:t>
+              <a:t>16/09/2026</a:t>
             </a:fld>
             <a:endParaRPr lang="es-PE"/>
           </a:p>
@@ -1834,7 +1834,7 @@
           <a:p>
             <a:fld id="{45F062A3-8868-478A-95F9-B75BA86CF6E5}" type="datetimeFigureOut">
               <a:rPr lang="es-PE" smtClean="0"/>
-              <a:t>11/09/2026</a:t>
+              <a:t>16/09/2026</a:t>
             </a:fld>
             <a:endParaRPr lang="es-PE"/>
           </a:p>
@@ -1976,7 +1976,7 @@
           <a:p>
             <a:fld id="{45F062A3-8868-478A-95F9-B75BA86CF6E5}" type="datetimeFigureOut">
               <a:rPr lang="es-PE" smtClean="0"/>
-              <a:t>11/09/2026</a:t>
+              <a:t>16/09/2026</a:t>
             </a:fld>
             <a:endParaRPr lang="es-PE"/>
           </a:p>
@@ -2089,7 +2089,7 @@
           <a:p>
             <a:fld id="{45F062A3-8868-478A-95F9-B75BA86CF6E5}" type="datetimeFigureOut">
               <a:rPr lang="es-PE" smtClean="0"/>
-              <a:t>11/09/2026</a:t>
+              <a:t>16/09/2026</a:t>
             </a:fld>
             <a:endParaRPr lang="es-PE"/>
           </a:p>
@@ -2402,7 +2402,7 @@
           <a:p>
             <a:fld id="{45F062A3-8868-478A-95F9-B75BA86CF6E5}" type="datetimeFigureOut">
               <a:rPr lang="es-PE" smtClean="0"/>
-              <a:t>11/09/2026</a:t>
+              <a:t>16/09/2026</a:t>
             </a:fld>
             <a:endParaRPr lang="es-PE"/>
           </a:p>
@@ -2691,7 +2691,7 @@
           <a:p>
             <a:fld id="{45F062A3-8868-478A-95F9-B75BA86CF6E5}" type="datetimeFigureOut">
               <a:rPr lang="es-PE" smtClean="0"/>
-              <a:t>11/09/2026</a:t>
+              <a:t>16/09/2026</a:t>
             </a:fld>
             <a:endParaRPr lang="es-PE"/>
           </a:p>
@@ -2934,7 +2934,7 @@
           <a:p>
             <a:fld id="{45F062A3-8868-478A-95F9-B75BA86CF6E5}" type="datetimeFigureOut">
               <a:rPr lang="es-PE" smtClean="0"/>
-              <a:t>11/09/2026</a:t>
+              <a:t>16/09/2026</a:t>
             </a:fld>
             <a:endParaRPr lang="es-PE"/>
           </a:p>
@@ -3695,14 +3695,11 @@
           <a:lstStyle/>
           <a:p>
             <a:pPr algn="ctr"/>
-            <a:r>
-              <a:rPr lang="es-PE" sz="2000" b="1" dirty="0">
-                <a:latin typeface="Calibri" panose="020F0502020204030204" pitchFamily="34" charset="0"/>
-                <a:ea typeface="Calibri" panose="020F0502020204030204" pitchFamily="34" charset="0"/>
-                <a:cs typeface="Calibri" panose="020F0502020204030204" pitchFamily="34" charset="0"/>
-              </a:rPr>
-              <a:t>{song1}</a:t>
-            </a:r>
+            <a:endParaRPr lang="es-PE" sz="2000" b="1" dirty="0">
+              <a:latin typeface="Calibri" panose="020F0502020204030204" pitchFamily="34" charset="0"/>
+              <a:ea typeface="Calibri" panose="020F0502020204030204" pitchFamily="34" charset="0"/>
+              <a:cs typeface="Calibri" panose="020F0502020204030204" pitchFamily="34" charset="0"/>
+            </a:endParaRPr>
           </a:p>
         </p:txBody>
       </p:sp>
@@ -3944,14 +3941,11 @@
           <a:lstStyle/>
           <a:p>
             <a:pPr algn="ctr"/>
-            <a:r>
-              <a:rPr lang="es-PE" sz="2000" b="1" dirty="0">
-                <a:latin typeface="Calibri" panose="020F0502020204030204" pitchFamily="34" charset="0"/>
-                <a:ea typeface="Calibri" panose="020F0502020204030204" pitchFamily="34" charset="0"/>
-                <a:cs typeface="Calibri" panose="020F0502020204030204" pitchFamily="34" charset="0"/>
-              </a:rPr>
-              <a:t>{song3}</a:t>
-            </a:r>
+            <a:endParaRPr lang="es-PE" sz="2000" b="1" dirty="0">
+              <a:latin typeface="Calibri" panose="020F0502020204030204" pitchFamily="34" charset="0"/>
+              <a:ea typeface="Calibri" panose="020F0502020204030204" pitchFamily="34" charset="0"/>
+              <a:cs typeface="Calibri" panose="020F0502020204030204" pitchFamily="34" charset="0"/>
+            </a:endParaRPr>
           </a:p>
         </p:txBody>
       </p:sp>
@@ -4193,14 +4187,11 @@
           <a:lstStyle/>
           <a:p>
             <a:pPr algn="ctr"/>
-            <a:r>
-              <a:rPr lang="es-PE" sz="2000" b="1" dirty="0">
-                <a:latin typeface="Calibri" panose="020F0502020204030204" pitchFamily="34" charset="0"/>
-                <a:ea typeface="Calibri" panose="020F0502020204030204" pitchFamily="34" charset="0"/>
-                <a:cs typeface="Calibri" panose="020F0502020204030204" pitchFamily="34" charset="0"/>
-              </a:rPr>
-              <a:t>{song2}</a:t>
-            </a:r>
+            <a:endParaRPr lang="es-PE" sz="2000" b="1" dirty="0">
+              <a:latin typeface="Calibri" panose="020F0502020204030204" pitchFamily="34" charset="0"/>
+              <a:ea typeface="Calibri" panose="020F0502020204030204" pitchFamily="34" charset="0"/>
+              <a:cs typeface="Calibri" panose="020F0502020204030204" pitchFamily="34" charset="0"/>
+            </a:endParaRPr>
           </a:p>
         </p:txBody>
       </p:sp>
@@ -4659,6 +4650,135 @@
                 <a:cs typeface="Calibri" panose="020F0502020204030204" pitchFamily="34" charset="0"/>
               </a:rPr>
               <a:t>{avatar}</a:t>
+            </a:r>
+          </a:p>
+        </p:txBody>
+      </p:sp>
+      <p:sp>
+        <p:nvSpPr>
+          <p:cNvPr id="17" name="TextBox 16">
+            <a:extLst>
+              <a:ext uri="{FF2B5EF4-FFF2-40B4-BE49-F238E27FC236}">
+                <a16:creationId xmlns:a16="http://schemas.microsoft.com/office/drawing/2014/main" id="{5C186528-021D-C28E-E6DE-C3847D65DD0C}"/>
+              </a:ext>
+            </a:extLst>
+          </p:cNvPr>
+          <p:cNvSpPr txBox="1"/>
+          <p:nvPr/>
+        </p:nvSpPr>
+        <p:spPr>
+          <a:xfrm>
+            <a:off x="2724150" y="1753004"/>
+            <a:ext cx="6743696" cy="369332"/>
+          </a:xfrm>
+          <a:prstGeom prst="rect">
+            <a:avLst/>
+          </a:prstGeom>
+          <a:noFill/>
+        </p:spPr>
+        <p:txBody>
+          <a:bodyPr wrap="square" rtlCol="0">
+            <a:spAutoFit/>
+          </a:bodyPr>
+          <a:lstStyle/>
+          <a:p>
+            <a:pPr algn="ctr"/>
+            <a:r>
+              <a:rPr lang="es-PE" b="1" dirty="0">
+                <a:solidFill>
+                  <a:schemeClr val="lt1"/>
+                </a:solidFill>
+                <a:latin typeface="Calibri" panose="020F0502020204030204" pitchFamily="34" charset="0"/>
+                <a:ea typeface="Calibri" panose="020F0502020204030204" pitchFamily="34" charset="0"/>
+                <a:cs typeface="Calibri" panose="020F0502020204030204" pitchFamily="34" charset="0"/>
+              </a:rPr>
+              <a:t>{song1}</a:t>
+            </a:r>
+          </a:p>
+        </p:txBody>
+      </p:sp>
+      <p:sp>
+        <p:nvSpPr>
+          <p:cNvPr id="19" name="TextBox 18">
+            <a:extLst>
+              <a:ext uri="{FF2B5EF4-FFF2-40B4-BE49-F238E27FC236}">
+                <a16:creationId xmlns:a16="http://schemas.microsoft.com/office/drawing/2014/main" id="{BB84422F-BEB0-7F1C-1CD2-D6370BD0550E}"/>
+              </a:ext>
+            </a:extLst>
+          </p:cNvPr>
+          <p:cNvSpPr txBox="1"/>
+          <p:nvPr/>
+        </p:nvSpPr>
+        <p:spPr>
+          <a:xfrm>
+            <a:off x="2724150" y="3380781"/>
+            <a:ext cx="6743696" cy="369332"/>
+          </a:xfrm>
+          <a:prstGeom prst="rect">
+            <a:avLst/>
+          </a:prstGeom>
+          <a:noFill/>
+        </p:spPr>
+        <p:txBody>
+          <a:bodyPr wrap="square" rtlCol="0">
+            <a:spAutoFit/>
+          </a:bodyPr>
+          <a:lstStyle/>
+          <a:p>
+            <a:pPr algn="ctr"/>
+            <a:r>
+              <a:rPr lang="es-PE" b="1" dirty="0">
+                <a:solidFill>
+                  <a:schemeClr val="lt1"/>
+                </a:solidFill>
+                <a:latin typeface="Calibri" panose="020F0502020204030204" pitchFamily="34" charset="0"/>
+                <a:ea typeface="Calibri" panose="020F0502020204030204" pitchFamily="34" charset="0"/>
+                <a:cs typeface="Calibri" panose="020F0502020204030204" pitchFamily="34" charset="0"/>
+              </a:rPr>
+              <a:t>{song2}</a:t>
+            </a:r>
+          </a:p>
+        </p:txBody>
+      </p:sp>
+      <p:sp>
+        <p:nvSpPr>
+          <p:cNvPr id="21" name="TextBox 20">
+            <a:extLst>
+              <a:ext uri="{FF2B5EF4-FFF2-40B4-BE49-F238E27FC236}">
+                <a16:creationId xmlns:a16="http://schemas.microsoft.com/office/drawing/2014/main" id="{1C76FA9D-2AEB-A467-6288-2995931A44BB}"/>
+              </a:ext>
+            </a:extLst>
+          </p:cNvPr>
+          <p:cNvSpPr txBox="1"/>
+          <p:nvPr/>
+        </p:nvSpPr>
+        <p:spPr>
+          <a:xfrm>
+            <a:off x="2724150" y="4990126"/>
+            <a:ext cx="6743696" cy="369332"/>
+          </a:xfrm>
+          <a:prstGeom prst="rect">
+            <a:avLst/>
+          </a:prstGeom>
+          <a:noFill/>
+        </p:spPr>
+        <p:txBody>
+          <a:bodyPr wrap="square" rtlCol="0">
+            <a:spAutoFit/>
+          </a:bodyPr>
+          <a:lstStyle/>
+          <a:p>
+            <a:pPr algn="ctr"/>
+            <a:r>
+              <a:rPr lang="es-PE" b="1" dirty="0">
+                <a:solidFill>
+                  <a:schemeClr val="lt1"/>
+                </a:solidFill>
+                <a:latin typeface="Calibri" panose="020F0502020204030204" pitchFamily="34" charset="0"/>
+                <a:ea typeface="Calibri" panose="020F0502020204030204" pitchFamily="34" charset="0"/>
+                <a:cs typeface="Calibri" panose="020F0502020204030204" pitchFamily="34" charset="0"/>
+              </a:rPr>
+              <a:t>{song3}</a:t>
             </a:r>
           </a:p>
         </p:txBody>
@@ -5189,23 +5309,20 @@
               <a:tabLst/>
               <a:defRPr/>
             </a:pPr>
-            <a:r>
-              <a:rPr kumimoji="0" lang="es-PE" sz="2000" b="1" i="0" u="none" strike="noStrike" kern="1200" cap="none" spc="0" normalizeH="0" baseline="0" noProof="0" dirty="0">
-                <a:ln>
-                  <a:noFill/>
-                </a:ln>
-                <a:solidFill>
-                  <a:prstClr val="white"/>
-                </a:solidFill>
-                <a:effectLst/>
-                <a:uLnTx/>
-                <a:uFillTx/>
-                <a:latin typeface="Calibri" panose="020F0502020204030204"/>
-                <a:ea typeface="+mn-ea"/>
-                <a:cs typeface="+mn-cs"/>
-              </a:rPr>
-              <a:t>{song1}</a:t>
-            </a:r>
+            <a:endParaRPr kumimoji="0" lang="es-PE" sz="2000" b="1" i="0" u="none" strike="noStrike" kern="1200" cap="none" spc="0" normalizeH="0" baseline="0" noProof="0" dirty="0">
+              <a:ln>
+                <a:noFill/>
+              </a:ln>
+              <a:solidFill>
+                <a:prstClr val="white"/>
+              </a:solidFill>
+              <a:effectLst/>
+              <a:uLnTx/>
+              <a:uFillTx/>
+              <a:latin typeface="Calibri" panose="020F0502020204030204"/>
+              <a:ea typeface="+mn-ea"/>
+              <a:cs typeface="+mn-cs"/>
+            </a:endParaRPr>
           </a:p>
         </p:txBody>
       </p:sp>
@@ -5538,23 +5655,20 @@
               <a:tabLst/>
               <a:defRPr/>
             </a:pPr>
-            <a:r>
-              <a:rPr kumimoji="0" lang="es-PE" sz="2000" b="1" i="0" u="none" strike="noStrike" kern="1200" cap="none" spc="0" normalizeH="0" baseline="0" noProof="0" dirty="0">
-                <a:ln>
-                  <a:noFill/>
-                </a:ln>
-                <a:solidFill>
-                  <a:prstClr val="white"/>
-                </a:solidFill>
-                <a:effectLst/>
-                <a:uLnTx/>
-                <a:uFillTx/>
-                <a:latin typeface="Calibri" panose="020F0502020204030204"/>
-                <a:ea typeface="+mn-ea"/>
-                <a:cs typeface="+mn-cs"/>
-              </a:rPr>
-              <a:t>{song3}</a:t>
-            </a:r>
+            <a:endParaRPr kumimoji="0" lang="es-PE" sz="2000" b="1" i="0" u="none" strike="noStrike" kern="1200" cap="none" spc="0" normalizeH="0" baseline="0" noProof="0" dirty="0">
+              <a:ln>
+                <a:noFill/>
+              </a:ln>
+              <a:solidFill>
+                <a:prstClr val="white"/>
+              </a:solidFill>
+              <a:effectLst/>
+              <a:uLnTx/>
+              <a:uFillTx/>
+              <a:latin typeface="Calibri" panose="020F0502020204030204"/>
+              <a:ea typeface="+mn-ea"/>
+              <a:cs typeface="+mn-cs"/>
+            </a:endParaRPr>
           </a:p>
         </p:txBody>
       </p:sp>
@@ -5887,23 +6001,20 @@
               <a:tabLst/>
               <a:defRPr/>
             </a:pPr>
-            <a:r>
-              <a:rPr kumimoji="0" lang="es-PE" sz="2000" b="1" i="0" u="none" strike="noStrike" kern="1200" cap="none" spc="0" normalizeH="0" baseline="0" noProof="0" dirty="0">
-                <a:ln>
-                  <a:noFill/>
-                </a:ln>
-                <a:solidFill>
-                  <a:prstClr val="white"/>
-                </a:solidFill>
-                <a:effectLst/>
-                <a:uLnTx/>
-                <a:uFillTx/>
-                <a:latin typeface="Calibri" panose="020F0502020204030204"/>
-                <a:ea typeface="+mn-ea"/>
-                <a:cs typeface="+mn-cs"/>
-              </a:rPr>
-              <a:t>{song2}</a:t>
-            </a:r>
+            <a:endParaRPr kumimoji="0" lang="es-PE" sz="2000" b="1" i="0" u="none" strike="noStrike" kern="1200" cap="none" spc="0" normalizeH="0" baseline="0" noProof="0" dirty="0">
+              <a:ln>
+                <a:noFill/>
+              </a:ln>
+              <a:solidFill>
+                <a:prstClr val="white"/>
+              </a:solidFill>
+              <a:effectLst/>
+              <a:uLnTx/>
+              <a:uFillTx/>
+              <a:latin typeface="Calibri" panose="020F0502020204030204"/>
+              <a:ea typeface="+mn-ea"/>
+              <a:cs typeface="+mn-cs"/>
+            </a:endParaRPr>
           </a:p>
         </p:txBody>
       </p:sp>
@@ -6657,6 +6768,135 @@
           </a:p>
         </p:txBody>
       </p:sp>
+      <p:sp>
+        <p:nvSpPr>
+          <p:cNvPr id="6" name="TextBox 5">
+            <a:extLst>
+              <a:ext uri="{FF2B5EF4-FFF2-40B4-BE49-F238E27FC236}">
+                <a16:creationId xmlns:a16="http://schemas.microsoft.com/office/drawing/2014/main" id="{6FE4B2F4-FC69-71EC-0EDA-1B8053E4AE4D}"/>
+              </a:ext>
+            </a:extLst>
+          </p:cNvPr>
+          <p:cNvSpPr txBox="1"/>
+          <p:nvPr/>
+        </p:nvSpPr>
+        <p:spPr>
+          <a:xfrm>
+            <a:off x="2724150" y="1753004"/>
+            <a:ext cx="6743696" cy="369332"/>
+          </a:xfrm>
+          <a:prstGeom prst="rect">
+            <a:avLst/>
+          </a:prstGeom>
+          <a:noFill/>
+        </p:spPr>
+        <p:txBody>
+          <a:bodyPr wrap="square" rtlCol="0">
+            <a:spAutoFit/>
+          </a:bodyPr>
+          <a:lstStyle/>
+          <a:p>
+            <a:pPr algn="ctr"/>
+            <a:r>
+              <a:rPr lang="es-PE" b="1" dirty="0">
+                <a:solidFill>
+                  <a:schemeClr val="lt1"/>
+                </a:solidFill>
+                <a:latin typeface="Calibri" panose="020F0502020204030204" pitchFamily="34" charset="0"/>
+                <a:ea typeface="Calibri" panose="020F0502020204030204" pitchFamily="34" charset="0"/>
+                <a:cs typeface="Calibri" panose="020F0502020204030204" pitchFamily="34" charset="0"/>
+              </a:rPr>
+              <a:t>{song1}</a:t>
+            </a:r>
+          </a:p>
+        </p:txBody>
+      </p:sp>
+      <p:sp>
+        <p:nvSpPr>
+          <p:cNvPr id="10" name="TextBox 9">
+            <a:extLst>
+              <a:ext uri="{FF2B5EF4-FFF2-40B4-BE49-F238E27FC236}">
+                <a16:creationId xmlns:a16="http://schemas.microsoft.com/office/drawing/2014/main" id="{E0BFCD50-3569-2620-25DF-2E0F757A60DC}"/>
+              </a:ext>
+            </a:extLst>
+          </p:cNvPr>
+          <p:cNvSpPr txBox="1"/>
+          <p:nvPr/>
+        </p:nvSpPr>
+        <p:spPr>
+          <a:xfrm>
+            <a:off x="2724150" y="3380781"/>
+            <a:ext cx="6743696" cy="369332"/>
+          </a:xfrm>
+          <a:prstGeom prst="rect">
+            <a:avLst/>
+          </a:prstGeom>
+          <a:noFill/>
+        </p:spPr>
+        <p:txBody>
+          <a:bodyPr wrap="square" rtlCol="0">
+            <a:spAutoFit/>
+          </a:bodyPr>
+          <a:lstStyle/>
+          <a:p>
+            <a:pPr algn="ctr"/>
+            <a:r>
+              <a:rPr lang="es-PE" b="1" dirty="0">
+                <a:solidFill>
+                  <a:schemeClr val="lt1"/>
+                </a:solidFill>
+                <a:latin typeface="Calibri" panose="020F0502020204030204" pitchFamily="34" charset="0"/>
+                <a:ea typeface="Calibri" panose="020F0502020204030204" pitchFamily="34" charset="0"/>
+                <a:cs typeface="Calibri" panose="020F0502020204030204" pitchFamily="34" charset="0"/>
+              </a:rPr>
+              <a:t>{song2}</a:t>
+            </a:r>
+          </a:p>
+        </p:txBody>
+      </p:sp>
+      <p:sp>
+        <p:nvSpPr>
+          <p:cNvPr id="17" name="TextBox 16">
+            <a:extLst>
+              <a:ext uri="{FF2B5EF4-FFF2-40B4-BE49-F238E27FC236}">
+                <a16:creationId xmlns:a16="http://schemas.microsoft.com/office/drawing/2014/main" id="{C4A1D63B-C2AA-2DA1-7320-D88C9CC66D2A}"/>
+              </a:ext>
+            </a:extLst>
+          </p:cNvPr>
+          <p:cNvSpPr txBox="1"/>
+          <p:nvPr/>
+        </p:nvSpPr>
+        <p:spPr>
+          <a:xfrm>
+            <a:off x="2724150" y="4990126"/>
+            <a:ext cx="6743696" cy="369332"/>
+          </a:xfrm>
+          <a:prstGeom prst="rect">
+            <a:avLst/>
+          </a:prstGeom>
+          <a:noFill/>
+        </p:spPr>
+        <p:txBody>
+          <a:bodyPr wrap="square" rtlCol="0">
+            <a:spAutoFit/>
+          </a:bodyPr>
+          <a:lstStyle/>
+          <a:p>
+            <a:pPr algn="ctr"/>
+            <a:r>
+              <a:rPr lang="es-PE" b="1" dirty="0">
+                <a:solidFill>
+                  <a:schemeClr val="lt1"/>
+                </a:solidFill>
+                <a:latin typeface="Calibri" panose="020F0502020204030204" pitchFamily="34" charset="0"/>
+                <a:ea typeface="Calibri" panose="020F0502020204030204" pitchFamily="34" charset="0"/>
+                <a:cs typeface="Calibri" panose="020F0502020204030204" pitchFamily="34" charset="0"/>
+              </a:rPr>
+              <a:t>{song3}</a:t>
+            </a:r>
+          </a:p>
+        </p:txBody>
+      </p:sp>
     </p:spTree>
     <p:extLst>
       <p:ext uri="{BB962C8B-B14F-4D97-AF65-F5344CB8AC3E}">
@@ -7183,23 +7423,20 @@
               <a:tabLst/>
               <a:defRPr/>
             </a:pPr>
-            <a:r>
-              <a:rPr kumimoji="0" lang="es-PE" sz="2000" b="1" i="0" u="none" strike="noStrike" kern="1200" cap="none" spc="0" normalizeH="0" baseline="0" noProof="0" dirty="0">
-                <a:ln>
-                  <a:noFill/>
-                </a:ln>
-                <a:solidFill>
-                  <a:prstClr val="white"/>
-                </a:solidFill>
-                <a:effectLst/>
-                <a:uLnTx/>
-                <a:uFillTx/>
-                <a:latin typeface="Calibri" panose="020F0502020204030204"/>
-                <a:ea typeface="+mn-ea"/>
-                <a:cs typeface="+mn-cs"/>
-              </a:rPr>
-              <a:t>{song1}</a:t>
-            </a:r>
+            <a:endParaRPr kumimoji="0" lang="es-PE" sz="2000" b="1" i="0" u="none" strike="noStrike" kern="1200" cap="none" spc="0" normalizeH="0" baseline="0" noProof="0" dirty="0">
+              <a:ln>
+                <a:noFill/>
+              </a:ln>
+              <a:solidFill>
+                <a:prstClr val="white"/>
+              </a:solidFill>
+              <a:effectLst/>
+              <a:uLnTx/>
+              <a:uFillTx/>
+              <a:latin typeface="Calibri" panose="020F0502020204030204"/>
+              <a:ea typeface="+mn-ea"/>
+              <a:cs typeface="+mn-cs"/>
+            </a:endParaRPr>
           </a:p>
         </p:txBody>
       </p:sp>
@@ -7532,23 +7769,20 @@
               <a:tabLst/>
               <a:defRPr/>
             </a:pPr>
-            <a:r>
-              <a:rPr kumimoji="0" lang="es-PE" sz="2000" b="1" i="0" u="none" strike="noStrike" kern="1200" cap="none" spc="0" normalizeH="0" baseline="0" noProof="0" dirty="0">
-                <a:ln>
-                  <a:noFill/>
-                </a:ln>
-                <a:solidFill>
-                  <a:prstClr val="white"/>
-                </a:solidFill>
-                <a:effectLst/>
-                <a:uLnTx/>
-                <a:uFillTx/>
-                <a:latin typeface="Calibri" panose="020F0502020204030204"/>
-                <a:ea typeface="+mn-ea"/>
-                <a:cs typeface="+mn-cs"/>
-              </a:rPr>
-              <a:t>{song3}</a:t>
-            </a:r>
+            <a:endParaRPr kumimoji="0" lang="es-PE" sz="2000" b="1" i="0" u="none" strike="noStrike" kern="1200" cap="none" spc="0" normalizeH="0" baseline="0" noProof="0" dirty="0">
+              <a:ln>
+                <a:noFill/>
+              </a:ln>
+              <a:solidFill>
+                <a:prstClr val="white"/>
+              </a:solidFill>
+              <a:effectLst/>
+              <a:uLnTx/>
+              <a:uFillTx/>
+              <a:latin typeface="Calibri" panose="020F0502020204030204"/>
+              <a:ea typeface="+mn-ea"/>
+              <a:cs typeface="+mn-cs"/>
+            </a:endParaRPr>
           </a:p>
         </p:txBody>
       </p:sp>
@@ -7881,23 +8115,20 @@
               <a:tabLst/>
               <a:defRPr/>
             </a:pPr>
-            <a:r>
-              <a:rPr kumimoji="0" lang="es-PE" sz="2000" b="1" i="0" u="none" strike="noStrike" kern="1200" cap="none" spc="0" normalizeH="0" baseline="0" noProof="0" dirty="0">
-                <a:ln>
-                  <a:noFill/>
-                </a:ln>
-                <a:solidFill>
-                  <a:prstClr val="white"/>
-                </a:solidFill>
-                <a:effectLst/>
-                <a:uLnTx/>
-                <a:uFillTx/>
-                <a:latin typeface="Calibri" panose="020F0502020204030204"/>
-                <a:ea typeface="+mn-ea"/>
-                <a:cs typeface="+mn-cs"/>
-              </a:rPr>
-              <a:t>{song2}</a:t>
-            </a:r>
+            <a:endParaRPr kumimoji="0" lang="es-PE" sz="2000" b="1" i="0" u="none" strike="noStrike" kern="1200" cap="none" spc="0" normalizeH="0" baseline="0" noProof="0" dirty="0">
+              <a:ln>
+                <a:noFill/>
+              </a:ln>
+              <a:solidFill>
+                <a:prstClr val="white"/>
+              </a:solidFill>
+              <a:effectLst/>
+              <a:uLnTx/>
+              <a:uFillTx/>
+              <a:latin typeface="Calibri" panose="020F0502020204030204"/>
+              <a:ea typeface="+mn-ea"/>
+              <a:cs typeface="+mn-cs"/>
+            </a:endParaRPr>
           </a:p>
         </p:txBody>
       </p:sp>
@@ -8651,6 +8882,135 @@
           </a:p>
         </p:txBody>
       </p:sp>
+      <p:sp>
+        <p:nvSpPr>
+          <p:cNvPr id="6" name="TextBox 5">
+            <a:extLst>
+              <a:ext uri="{FF2B5EF4-FFF2-40B4-BE49-F238E27FC236}">
+                <a16:creationId xmlns:a16="http://schemas.microsoft.com/office/drawing/2014/main" id="{A2AF6D7F-F105-406E-5309-6E9A241077C3}"/>
+              </a:ext>
+            </a:extLst>
+          </p:cNvPr>
+          <p:cNvSpPr txBox="1"/>
+          <p:nvPr/>
+        </p:nvSpPr>
+        <p:spPr>
+          <a:xfrm>
+            <a:off x="2724150" y="1753004"/>
+            <a:ext cx="6743696" cy="369332"/>
+          </a:xfrm>
+          <a:prstGeom prst="rect">
+            <a:avLst/>
+          </a:prstGeom>
+          <a:noFill/>
+        </p:spPr>
+        <p:txBody>
+          <a:bodyPr wrap="square" rtlCol="0">
+            <a:spAutoFit/>
+          </a:bodyPr>
+          <a:lstStyle/>
+          <a:p>
+            <a:pPr algn="ctr"/>
+            <a:r>
+              <a:rPr lang="es-PE" b="1" dirty="0">
+                <a:solidFill>
+                  <a:schemeClr val="lt1"/>
+                </a:solidFill>
+                <a:latin typeface="Calibri" panose="020F0502020204030204" pitchFamily="34" charset="0"/>
+                <a:ea typeface="Calibri" panose="020F0502020204030204" pitchFamily="34" charset="0"/>
+                <a:cs typeface="Calibri" panose="020F0502020204030204" pitchFamily="34" charset="0"/>
+              </a:rPr>
+              <a:t>{song1}</a:t>
+            </a:r>
+          </a:p>
+        </p:txBody>
+      </p:sp>
+      <p:sp>
+        <p:nvSpPr>
+          <p:cNvPr id="10" name="TextBox 9">
+            <a:extLst>
+              <a:ext uri="{FF2B5EF4-FFF2-40B4-BE49-F238E27FC236}">
+                <a16:creationId xmlns:a16="http://schemas.microsoft.com/office/drawing/2014/main" id="{CFE0E386-6248-41C6-44C0-1DDADCD0F0C0}"/>
+              </a:ext>
+            </a:extLst>
+          </p:cNvPr>
+          <p:cNvSpPr txBox="1"/>
+          <p:nvPr/>
+        </p:nvSpPr>
+        <p:spPr>
+          <a:xfrm>
+            <a:off x="2724150" y="3380781"/>
+            <a:ext cx="6743696" cy="369332"/>
+          </a:xfrm>
+          <a:prstGeom prst="rect">
+            <a:avLst/>
+          </a:prstGeom>
+          <a:noFill/>
+        </p:spPr>
+        <p:txBody>
+          <a:bodyPr wrap="square" rtlCol="0">
+            <a:spAutoFit/>
+          </a:bodyPr>
+          <a:lstStyle/>
+          <a:p>
+            <a:pPr algn="ctr"/>
+            <a:r>
+              <a:rPr lang="es-PE" b="1" dirty="0">
+                <a:solidFill>
+                  <a:schemeClr val="lt1"/>
+                </a:solidFill>
+                <a:latin typeface="Calibri" panose="020F0502020204030204" pitchFamily="34" charset="0"/>
+                <a:ea typeface="Calibri" panose="020F0502020204030204" pitchFamily="34" charset="0"/>
+                <a:cs typeface="Calibri" panose="020F0502020204030204" pitchFamily="34" charset="0"/>
+              </a:rPr>
+              <a:t>{song2}</a:t>
+            </a:r>
+          </a:p>
+        </p:txBody>
+      </p:sp>
+      <p:sp>
+        <p:nvSpPr>
+          <p:cNvPr id="17" name="TextBox 16">
+            <a:extLst>
+              <a:ext uri="{FF2B5EF4-FFF2-40B4-BE49-F238E27FC236}">
+                <a16:creationId xmlns:a16="http://schemas.microsoft.com/office/drawing/2014/main" id="{BD159FB1-5BB2-69C5-3451-1D5151C45899}"/>
+              </a:ext>
+            </a:extLst>
+          </p:cNvPr>
+          <p:cNvSpPr txBox="1"/>
+          <p:nvPr/>
+        </p:nvSpPr>
+        <p:spPr>
+          <a:xfrm>
+            <a:off x="2724150" y="4990126"/>
+            <a:ext cx="6743696" cy="369332"/>
+          </a:xfrm>
+          <a:prstGeom prst="rect">
+            <a:avLst/>
+          </a:prstGeom>
+          <a:noFill/>
+        </p:spPr>
+        <p:txBody>
+          <a:bodyPr wrap="square" rtlCol="0">
+            <a:spAutoFit/>
+          </a:bodyPr>
+          <a:lstStyle/>
+          <a:p>
+            <a:pPr algn="ctr"/>
+            <a:r>
+              <a:rPr lang="es-PE" b="1" dirty="0">
+                <a:solidFill>
+                  <a:schemeClr val="lt1"/>
+                </a:solidFill>
+                <a:latin typeface="Calibri" panose="020F0502020204030204" pitchFamily="34" charset="0"/>
+                <a:ea typeface="Calibri" panose="020F0502020204030204" pitchFamily="34" charset="0"/>
+                <a:cs typeface="Calibri" panose="020F0502020204030204" pitchFamily="34" charset="0"/>
+              </a:rPr>
+              <a:t>{song3}</a:t>
+            </a:r>
+          </a:p>
+        </p:txBody>
+      </p:sp>
     </p:spTree>
     <p:extLst>
       <p:ext uri="{BB962C8B-B14F-4D97-AF65-F5344CB8AC3E}">
@@ -9177,23 +9537,20 @@
               <a:tabLst/>
               <a:defRPr/>
             </a:pPr>
-            <a:r>
-              <a:rPr kumimoji="0" lang="es-PE" sz="2000" b="1" i="0" u="none" strike="noStrike" kern="1200" cap="none" spc="0" normalizeH="0" baseline="0" noProof="0" dirty="0">
-                <a:ln>
-                  <a:noFill/>
-                </a:ln>
-                <a:solidFill>
-                  <a:prstClr val="white"/>
-                </a:solidFill>
-                <a:effectLst/>
-                <a:uLnTx/>
-                <a:uFillTx/>
-                <a:latin typeface="Calibri" panose="020F0502020204030204"/>
-                <a:ea typeface="+mn-ea"/>
-                <a:cs typeface="+mn-cs"/>
-              </a:rPr>
-              <a:t>{song1}</a:t>
-            </a:r>
+            <a:endParaRPr kumimoji="0" lang="es-PE" sz="2000" b="1" i="0" u="none" strike="noStrike" kern="1200" cap="none" spc="0" normalizeH="0" baseline="0" noProof="0" dirty="0">
+              <a:ln>
+                <a:noFill/>
+              </a:ln>
+              <a:solidFill>
+                <a:prstClr val="white"/>
+              </a:solidFill>
+              <a:effectLst/>
+              <a:uLnTx/>
+              <a:uFillTx/>
+              <a:latin typeface="Calibri" panose="020F0502020204030204"/>
+              <a:ea typeface="+mn-ea"/>
+              <a:cs typeface="+mn-cs"/>
+            </a:endParaRPr>
           </a:p>
         </p:txBody>
       </p:sp>
@@ -9526,23 +9883,20 @@
               <a:tabLst/>
               <a:defRPr/>
             </a:pPr>
-            <a:r>
-              <a:rPr kumimoji="0" lang="es-PE" sz="2000" b="1" i="0" u="none" strike="noStrike" kern="1200" cap="none" spc="0" normalizeH="0" baseline="0" noProof="0" dirty="0">
-                <a:ln>
-                  <a:noFill/>
-                </a:ln>
-                <a:solidFill>
-                  <a:prstClr val="white"/>
-                </a:solidFill>
-                <a:effectLst/>
-                <a:uLnTx/>
-                <a:uFillTx/>
-                <a:latin typeface="Calibri" panose="020F0502020204030204"/>
-                <a:ea typeface="+mn-ea"/>
-                <a:cs typeface="+mn-cs"/>
-              </a:rPr>
-              <a:t>{song3}</a:t>
-            </a:r>
+            <a:endParaRPr kumimoji="0" lang="es-PE" sz="2000" b="1" i="0" u="none" strike="noStrike" kern="1200" cap="none" spc="0" normalizeH="0" baseline="0" noProof="0" dirty="0">
+              <a:ln>
+                <a:noFill/>
+              </a:ln>
+              <a:solidFill>
+                <a:prstClr val="white"/>
+              </a:solidFill>
+              <a:effectLst/>
+              <a:uLnTx/>
+              <a:uFillTx/>
+              <a:latin typeface="Calibri" panose="020F0502020204030204"/>
+              <a:ea typeface="+mn-ea"/>
+              <a:cs typeface="+mn-cs"/>
+            </a:endParaRPr>
           </a:p>
         </p:txBody>
       </p:sp>
@@ -9875,23 +10229,20 @@
               <a:tabLst/>
               <a:defRPr/>
             </a:pPr>
-            <a:r>
-              <a:rPr kumimoji="0" lang="es-PE" sz="2000" b="1" i="0" u="none" strike="noStrike" kern="1200" cap="none" spc="0" normalizeH="0" baseline="0" noProof="0" dirty="0">
-                <a:ln>
-                  <a:noFill/>
-                </a:ln>
-                <a:solidFill>
-                  <a:prstClr val="white"/>
-                </a:solidFill>
-                <a:effectLst/>
-                <a:uLnTx/>
-                <a:uFillTx/>
-                <a:latin typeface="Calibri" panose="020F0502020204030204"/>
-                <a:ea typeface="+mn-ea"/>
-                <a:cs typeface="+mn-cs"/>
-              </a:rPr>
-              <a:t>{song2}</a:t>
-            </a:r>
+            <a:endParaRPr kumimoji="0" lang="es-PE" sz="2000" b="1" i="0" u="none" strike="noStrike" kern="1200" cap="none" spc="0" normalizeH="0" baseline="0" noProof="0" dirty="0">
+              <a:ln>
+                <a:noFill/>
+              </a:ln>
+              <a:solidFill>
+                <a:prstClr val="white"/>
+              </a:solidFill>
+              <a:effectLst/>
+              <a:uLnTx/>
+              <a:uFillTx/>
+              <a:latin typeface="Calibri" panose="020F0502020204030204"/>
+              <a:ea typeface="+mn-ea"/>
+              <a:cs typeface="+mn-cs"/>
+            </a:endParaRPr>
           </a:p>
         </p:txBody>
       </p:sp>
@@ -10645,6 +10996,135 @@
           </a:p>
         </p:txBody>
       </p:sp>
+      <p:sp>
+        <p:nvSpPr>
+          <p:cNvPr id="6" name="TextBox 5">
+            <a:extLst>
+              <a:ext uri="{FF2B5EF4-FFF2-40B4-BE49-F238E27FC236}">
+                <a16:creationId xmlns:a16="http://schemas.microsoft.com/office/drawing/2014/main" id="{520A7B2D-D805-801F-95FC-DE31D9767588}"/>
+              </a:ext>
+            </a:extLst>
+          </p:cNvPr>
+          <p:cNvSpPr txBox="1"/>
+          <p:nvPr/>
+        </p:nvSpPr>
+        <p:spPr>
+          <a:xfrm>
+            <a:off x="2724150" y="1753004"/>
+            <a:ext cx="6743696" cy="369332"/>
+          </a:xfrm>
+          <a:prstGeom prst="rect">
+            <a:avLst/>
+          </a:prstGeom>
+          <a:noFill/>
+        </p:spPr>
+        <p:txBody>
+          <a:bodyPr wrap="square" rtlCol="0">
+            <a:spAutoFit/>
+          </a:bodyPr>
+          <a:lstStyle/>
+          <a:p>
+            <a:pPr algn="ctr"/>
+            <a:r>
+              <a:rPr lang="es-PE" b="1" dirty="0">
+                <a:solidFill>
+                  <a:schemeClr val="lt1"/>
+                </a:solidFill>
+                <a:latin typeface="Calibri" panose="020F0502020204030204" pitchFamily="34" charset="0"/>
+                <a:ea typeface="Calibri" panose="020F0502020204030204" pitchFamily="34" charset="0"/>
+                <a:cs typeface="Calibri" panose="020F0502020204030204" pitchFamily="34" charset="0"/>
+              </a:rPr>
+              <a:t>{song1}</a:t>
+            </a:r>
+          </a:p>
+        </p:txBody>
+      </p:sp>
+      <p:sp>
+        <p:nvSpPr>
+          <p:cNvPr id="10" name="TextBox 9">
+            <a:extLst>
+              <a:ext uri="{FF2B5EF4-FFF2-40B4-BE49-F238E27FC236}">
+                <a16:creationId xmlns:a16="http://schemas.microsoft.com/office/drawing/2014/main" id="{60DA659D-2043-B285-5AED-78109FD3B679}"/>
+              </a:ext>
+            </a:extLst>
+          </p:cNvPr>
+          <p:cNvSpPr txBox="1"/>
+          <p:nvPr/>
+        </p:nvSpPr>
+        <p:spPr>
+          <a:xfrm>
+            <a:off x="2724150" y="3380781"/>
+            <a:ext cx="6743696" cy="369332"/>
+          </a:xfrm>
+          <a:prstGeom prst="rect">
+            <a:avLst/>
+          </a:prstGeom>
+          <a:noFill/>
+        </p:spPr>
+        <p:txBody>
+          <a:bodyPr wrap="square" rtlCol="0">
+            <a:spAutoFit/>
+          </a:bodyPr>
+          <a:lstStyle/>
+          <a:p>
+            <a:pPr algn="ctr"/>
+            <a:r>
+              <a:rPr lang="es-PE" b="1" dirty="0">
+                <a:solidFill>
+                  <a:schemeClr val="lt1"/>
+                </a:solidFill>
+                <a:latin typeface="Calibri" panose="020F0502020204030204" pitchFamily="34" charset="0"/>
+                <a:ea typeface="Calibri" panose="020F0502020204030204" pitchFamily="34" charset="0"/>
+                <a:cs typeface="Calibri" panose="020F0502020204030204" pitchFamily="34" charset="0"/>
+              </a:rPr>
+              <a:t>{song2}</a:t>
+            </a:r>
+          </a:p>
+        </p:txBody>
+      </p:sp>
+      <p:sp>
+        <p:nvSpPr>
+          <p:cNvPr id="17" name="TextBox 16">
+            <a:extLst>
+              <a:ext uri="{FF2B5EF4-FFF2-40B4-BE49-F238E27FC236}">
+                <a16:creationId xmlns:a16="http://schemas.microsoft.com/office/drawing/2014/main" id="{29757AB1-A105-591D-83DC-0472DFA66BA7}"/>
+              </a:ext>
+            </a:extLst>
+          </p:cNvPr>
+          <p:cNvSpPr txBox="1"/>
+          <p:nvPr/>
+        </p:nvSpPr>
+        <p:spPr>
+          <a:xfrm>
+            <a:off x="2724150" y="4990126"/>
+            <a:ext cx="6743696" cy="369332"/>
+          </a:xfrm>
+          <a:prstGeom prst="rect">
+            <a:avLst/>
+          </a:prstGeom>
+          <a:noFill/>
+        </p:spPr>
+        <p:txBody>
+          <a:bodyPr wrap="square" rtlCol="0">
+            <a:spAutoFit/>
+          </a:bodyPr>
+          <a:lstStyle/>
+          <a:p>
+            <a:pPr algn="ctr"/>
+            <a:r>
+              <a:rPr lang="es-PE" b="1" dirty="0">
+                <a:solidFill>
+                  <a:schemeClr val="lt1"/>
+                </a:solidFill>
+                <a:latin typeface="Calibri" panose="020F0502020204030204" pitchFamily="34" charset="0"/>
+                <a:ea typeface="Calibri" panose="020F0502020204030204" pitchFamily="34" charset="0"/>
+                <a:cs typeface="Calibri" panose="020F0502020204030204" pitchFamily="34" charset="0"/>
+              </a:rPr>
+              <a:t>{song3}</a:t>
+            </a:r>
+          </a:p>
+        </p:txBody>
+      </p:sp>
     </p:spTree>
     <p:extLst>
       <p:ext uri="{BB962C8B-B14F-4D97-AF65-F5344CB8AC3E}">
@@ -11169,23 +11649,20 @@
               <a:tabLst/>
               <a:defRPr/>
             </a:pPr>
-            <a:r>
-              <a:rPr kumimoji="0" lang="es-PE" sz="2000" b="1" i="0" u="none" strike="noStrike" kern="1200" cap="none" spc="0" normalizeH="0" baseline="0" noProof="0" dirty="0">
-                <a:ln>
-                  <a:noFill/>
-                </a:ln>
-                <a:solidFill>
-                  <a:prstClr val="white"/>
-                </a:solidFill>
-                <a:effectLst/>
-                <a:uLnTx/>
-                <a:uFillTx/>
-                <a:latin typeface="Calibri" panose="020F0502020204030204"/>
-                <a:ea typeface="+mn-ea"/>
-                <a:cs typeface="+mn-cs"/>
-              </a:rPr>
-              <a:t>{song1}</a:t>
-            </a:r>
+            <a:endParaRPr kumimoji="0" lang="es-PE" sz="2000" b="1" i="0" u="none" strike="noStrike" kern="1200" cap="none" spc="0" normalizeH="0" baseline="0" noProof="0" dirty="0">
+              <a:ln>
+                <a:noFill/>
+              </a:ln>
+              <a:solidFill>
+                <a:prstClr val="white"/>
+              </a:solidFill>
+              <a:effectLst/>
+              <a:uLnTx/>
+              <a:uFillTx/>
+              <a:latin typeface="Calibri" panose="020F0502020204030204"/>
+              <a:ea typeface="+mn-ea"/>
+              <a:cs typeface="+mn-cs"/>
+            </a:endParaRPr>
           </a:p>
         </p:txBody>
       </p:sp>
@@ -11518,23 +11995,20 @@
               <a:tabLst/>
               <a:defRPr/>
             </a:pPr>
-            <a:r>
-              <a:rPr kumimoji="0" lang="es-PE" sz="2000" b="1" i="0" u="none" strike="noStrike" kern="1200" cap="none" spc="0" normalizeH="0" baseline="0" noProof="0" dirty="0">
-                <a:ln>
-                  <a:noFill/>
-                </a:ln>
-                <a:solidFill>
-                  <a:prstClr val="white"/>
-                </a:solidFill>
-                <a:effectLst/>
-                <a:uLnTx/>
-                <a:uFillTx/>
-                <a:latin typeface="Calibri" panose="020F0502020204030204"/>
-                <a:ea typeface="+mn-ea"/>
-                <a:cs typeface="+mn-cs"/>
-              </a:rPr>
-              <a:t>{song3}</a:t>
-            </a:r>
+            <a:endParaRPr kumimoji="0" lang="es-PE" sz="2000" b="1" i="0" u="none" strike="noStrike" kern="1200" cap="none" spc="0" normalizeH="0" baseline="0" noProof="0" dirty="0">
+              <a:ln>
+                <a:noFill/>
+              </a:ln>
+              <a:solidFill>
+                <a:prstClr val="white"/>
+              </a:solidFill>
+              <a:effectLst/>
+              <a:uLnTx/>
+              <a:uFillTx/>
+              <a:latin typeface="Calibri" panose="020F0502020204030204"/>
+              <a:ea typeface="+mn-ea"/>
+              <a:cs typeface="+mn-cs"/>
+            </a:endParaRPr>
           </a:p>
         </p:txBody>
       </p:sp>
@@ -11867,23 +12341,20 @@
               <a:tabLst/>
               <a:defRPr/>
             </a:pPr>
-            <a:r>
-              <a:rPr kumimoji="0" lang="es-PE" sz="2000" b="1" i="0" u="none" strike="noStrike" kern="1200" cap="none" spc="0" normalizeH="0" baseline="0" noProof="0" dirty="0">
-                <a:ln>
-                  <a:noFill/>
-                </a:ln>
-                <a:solidFill>
-                  <a:prstClr val="white"/>
-                </a:solidFill>
-                <a:effectLst/>
-                <a:uLnTx/>
-                <a:uFillTx/>
-                <a:latin typeface="Calibri" panose="020F0502020204030204"/>
-                <a:ea typeface="+mn-ea"/>
-                <a:cs typeface="+mn-cs"/>
-              </a:rPr>
-              <a:t>{song2}</a:t>
-            </a:r>
+            <a:endParaRPr kumimoji="0" lang="es-PE" sz="2000" b="1" i="0" u="none" strike="noStrike" kern="1200" cap="none" spc="0" normalizeH="0" baseline="0" noProof="0" dirty="0">
+              <a:ln>
+                <a:noFill/>
+              </a:ln>
+              <a:solidFill>
+                <a:prstClr val="white"/>
+              </a:solidFill>
+              <a:effectLst/>
+              <a:uLnTx/>
+              <a:uFillTx/>
+              <a:latin typeface="Calibri" panose="020F0502020204030204"/>
+              <a:ea typeface="+mn-ea"/>
+              <a:cs typeface="+mn-cs"/>
+            </a:endParaRPr>
           </a:p>
         </p:txBody>
       </p:sp>
@@ -12633,6 +13104,135 @@
                 <a:cs typeface="+mn-cs"/>
               </a:rPr>
               <a:t>{avatar}</a:t>
+            </a:r>
+          </a:p>
+        </p:txBody>
+      </p:sp>
+      <p:sp>
+        <p:nvSpPr>
+          <p:cNvPr id="4" name="TextBox 3">
+            <a:extLst>
+              <a:ext uri="{FF2B5EF4-FFF2-40B4-BE49-F238E27FC236}">
+                <a16:creationId xmlns:a16="http://schemas.microsoft.com/office/drawing/2014/main" id="{B37B4034-B3DD-D0AF-BEBD-81A85A8744C4}"/>
+              </a:ext>
+            </a:extLst>
+          </p:cNvPr>
+          <p:cNvSpPr txBox="1"/>
+          <p:nvPr/>
+        </p:nvSpPr>
+        <p:spPr>
+          <a:xfrm>
+            <a:off x="2724150" y="1753004"/>
+            <a:ext cx="6743696" cy="369332"/>
+          </a:xfrm>
+          <a:prstGeom prst="rect">
+            <a:avLst/>
+          </a:prstGeom>
+          <a:noFill/>
+        </p:spPr>
+        <p:txBody>
+          <a:bodyPr wrap="square" rtlCol="0">
+            <a:spAutoFit/>
+          </a:bodyPr>
+          <a:lstStyle/>
+          <a:p>
+            <a:pPr algn="ctr"/>
+            <a:r>
+              <a:rPr lang="es-PE" b="1" dirty="0">
+                <a:solidFill>
+                  <a:schemeClr val="lt1"/>
+                </a:solidFill>
+                <a:latin typeface="Calibri" panose="020F0502020204030204" pitchFamily="34" charset="0"/>
+                <a:ea typeface="Calibri" panose="020F0502020204030204" pitchFamily="34" charset="0"/>
+                <a:cs typeface="Calibri" panose="020F0502020204030204" pitchFamily="34" charset="0"/>
+              </a:rPr>
+              <a:t>{song1}</a:t>
+            </a:r>
+          </a:p>
+        </p:txBody>
+      </p:sp>
+      <p:sp>
+        <p:nvSpPr>
+          <p:cNvPr id="9" name="TextBox 8">
+            <a:extLst>
+              <a:ext uri="{FF2B5EF4-FFF2-40B4-BE49-F238E27FC236}">
+                <a16:creationId xmlns:a16="http://schemas.microsoft.com/office/drawing/2014/main" id="{FD044A73-62C1-6E90-E654-73BBDAF87538}"/>
+              </a:ext>
+            </a:extLst>
+          </p:cNvPr>
+          <p:cNvSpPr txBox="1"/>
+          <p:nvPr/>
+        </p:nvSpPr>
+        <p:spPr>
+          <a:xfrm>
+            <a:off x="2724150" y="3380781"/>
+            <a:ext cx="6743696" cy="369332"/>
+          </a:xfrm>
+          <a:prstGeom prst="rect">
+            <a:avLst/>
+          </a:prstGeom>
+          <a:noFill/>
+        </p:spPr>
+        <p:txBody>
+          <a:bodyPr wrap="square" rtlCol="0">
+            <a:spAutoFit/>
+          </a:bodyPr>
+          <a:lstStyle/>
+          <a:p>
+            <a:pPr algn="ctr"/>
+            <a:r>
+              <a:rPr lang="es-PE" b="1" dirty="0">
+                <a:solidFill>
+                  <a:schemeClr val="lt1"/>
+                </a:solidFill>
+                <a:latin typeface="Calibri" panose="020F0502020204030204" pitchFamily="34" charset="0"/>
+                <a:ea typeface="Calibri" panose="020F0502020204030204" pitchFamily="34" charset="0"/>
+                <a:cs typeface="Calibri" panose="020F0502020204030204" pitchFamily="34" charset="0"/>
+              </a:rPr>
+              <a:t>{song2}</a:t>
+            </a:r>
+          </a:p>
+        </p:txBody>
+      </p:sp>
+      <p:sp>
+        <p:nvSpPr>
+          <p:cNvPr id="17" name="TextBox 16">
+            <a:extLst>
+              <a:ext uri="{FF2B5EF4-FFF2-40B4-BE49-F238E27FC236}">
+                <a16:creationId xmlns:a16="http://schemas.microsoft.com/office/drawing/2014/main" id="{7BFCBD86-384B-47B9-C2C8-99BA1EB33D25}"/>
+              </a:ext>
+            </a:extLst>
+          </p:cNvPr>
+          <p:cNvSpPr txBox="1"/>
+          <p:nvPr/>
+        </p:nvSpPr>
+        <p:spPr>
+          <a:xfrm>
+            <a:off x="2724150" y="4990126"/>
+            <a:ext cx="6743696" cy="369332"/>
+          </a:xfrm>
+          <a:prstGeom prst="rect">
+            <a:avLst/>
+          </a:prstGeom>
+          <a:noFill/>
+        </p:spPr>
+        <p:txBody>
+          <a:bodyPr wrap="square" rtlCol="0">
+            <a:spAutoFit/>
+          </a:bodyPr>
+          <a:lstStyle/>
+          <a:p>
+            <a:pPr algn="ctr"/>
+            <a:r>
+              <a:rPr lang="es-PE" b="1" dirty="0">
+                <a:solidFill>
+                  <a:schemeClr val="lt1"/>
+                </a:solidFill>
+                <a:latin typeface="Calibri" panose="020F0502020204030204" pitchFamily="34" charset="0"/>
+                <a:ea typeface="Calibri" panose="020F0502020204030204" pitchFamily="34" charset="0"/>
+                <a:cs typeface="Calibri" panose="020F0502020204030204" pitchFamily="34" charset="0"/>
+              </a:rPr>
+              <a:t>{song3}</a:t>
             </a:r>
           </a:p>
         </p:txBody>

</xml_diff>